<commit_message>
Update INARA 2026-08-27 17:22:22
</commit_message>
<xml_diff>
--- a/reports/BRANCH_DENPASAR_PERFORMANCE_SUMMARY_20260826_INARA.pptx
+++ b/reports/BRANCH_DENPASAR_PERFORMANCE_SUMMARY_20260826_INARA.pptx
@@ -26095,7 +26095,7 @@
                           </a:solidFill>
                           <a:latin typeface="Arial"/>
                         </a:rPr>
-                        <a:t>2.133</a:t>
+                        <a:t>2.228</a:t>
                       </a:r>
                     </a:p>
                   </a:txBody>
@@ -26142,7 +26142,7 @@
                           </a:solidFill>
                           <a:latin typeface="Arial"/>
                         </a:rPr>
-                        <a:t>5.026</a:t>
+                        <a:t>5.053</a:t>
                       </a:r>
                     </a:p>
                   </a:txBody>
@@ -26189,7 +26189,7 @@
                           </a:solidFill>
                           <a:latin typeface="Arial"/>
                         </a:rPr>
-                        <a:t>32.234</a:t>
+                        <a:t>32.155</a:t>
                       </a:r>
                     </a:p>
                   </a:txBody>
@@ -26236,7 +26236,7 @@
                           </a:solidFill>
                           <a:latin typeface="Arial"/>
                         </a:rPr>
-                        <a:t>4.584</a:t>
+                        <a:t>4.571</a:t>
                       </a:r>
                     </a:p>
                   </a:txBody>
@@ -26283,7 +26283,7 @@
                           </a:solidFill>
                           <a:latin typeface="Arial"/>
                         </a:rPr>
-                        <a:t>3.300</a:t>
+                        <a:t>3.291</a:t>
                       </a:r>
                     </a:p>
                   </a:txBody>
@@ -26330,7 +26330,7 @@
                           </a:solidFill>
                           <a:latin typeface="Arial"/>
                         </a:rPr>
-                        <a:t>47.277</a:t>
+                        <a:t>47.298</a:t>
                       </a:r>
                     </a:p>
                   </a:txBody>
@@ -26379,7 +26379,7 @@
                           </a:solidFill>
                           <a:latin typeface="Arial"/>
                         </a:rPr>
-                        <a:t>4,5%</a:t>
+                        <a:t>4,7%</a:t>
                       </a:r>
                     </a:p>
                   </a:txBody>
@@ -26426,7 +26426,7 @@
                           </a:solidFill>
                           <a:latin typeface="Arial"/>
                         </a:rPr>
-                        <a:t>10,6%</a:t>
+                        <a:t>10,7%</a:t>
                       </a:r>
                     </a:p>
                   </a:txBody>
@@ -26473,7 +26473,7 @@
                           </a:solidFill>
                           <a:latin typeface="Arial"/>
                         </a:rPr>
-                        <a:t>68,2%</a:t>
+                        <a:t>68,0%</a:t>
                       </a:r>
                     </a:p>
                   </a:txBody>
@@ -26800,7 +26800,7 @@
                 </a:solidFill>
                 <a:latin typeface="Arial"/>
               </a:rPr>
-              <a:t>Jumlah ODP  3.300</a:t>
+              <a:t>Jumlah ODP  3.291</a:t>
             </a:r>
           </a:p>
         </p:txBody>
@@ -26835,7 +26835,7 @@
                 </a:solidFill>
                 <a:latin typeface="Arial"/>
               </a:rPr>
-              <a:t>ODP dikunjungi  552 (16,7%)</a:t>
+              <a:t>ODP dikunjungi  541 (16,4%)</a:t>
             </a:r>
           </a:p>
         </p:txBody>
@@ -26905,7 +26905,7 @@
                 </a:solidFill>
                 <a:latin typeface="Arial"/>
               </a:rPr>
-              <a:t>1.676</a:t>
+              <a:t>1.655</a:t>
             </a:r>
           </a:p>
         </p:txBody>
@@ -27022,7 +27022,7 @@
                 </a:solidFill>
                 <a:latin typeface="Arial"/>
               </a:rPr>
-              <a:t>Jumlah ODP  275</a:t>
+              <a:t>Jumlah ODP  327</a:t>
             </a:r>
           </a:p>
         </p:txBody>
@@ -27057,7 +27057,7 @@
                 </a:solidFill>
                 <a:latin typeface="Arial"/>
               </a:rPr>
-              <a:t>ODP dikunjungi  190 (69,1%)</a:t>
+              <a:t>ODP dikunjungi  196 (59,9%)</a:t>
             </a:r>
           </a:p>
         </p:txBody>
@@ -27127,7 +27127,7 @@
                 </a:solidFill>
                 <a:latin typeface="Arial"/>
               </a:rPr>
-              <a:t>455</a:t>
+              <a:t>479</a:t>
             </a:r>
           </a:p>
         </p:txBody>

</xml_diff>